<commit_message>
Paniere di Starlink spiegato e frase sui multipli corretta
Il grafico dei comparabili mostra come si forma ogni paniere (media dei
settori pesata sul mix: per Starlink, Starshield ai multipli della
difesa). Corretta la frase sul multiplo richiesto a Starlink: AST
SpaceMobile e Globalstar sono sopra ma senza ricavi a regime.

Co-Authored-By: Claude Opus 5.5 <noreply@anthropic.com>
</commit_message>
<xml_diff>
--- a/documenti/SpaceX_prezzo_e_valore.pptx
+++ b/documenti/SpaceX_prezzo_e_valore.pptx
@@ -2286,7 +2286,7 @@
           <a:p>
             <a:r>
               <a:rPr lang="en-US" dirty="0"/>
-              <a:t>Primo strumento, i multipli. Il corso dice che i comparabili devono avere stesso rischio e stessa crescita, e che trovarli è difficile. Per SpaceX un comparabile non esiste. Ma la SEC ci dà tre segmenti: Space, cioè lanci e contratti con NASA e Difesa; Starlink; e l'AI, cioè xAI. Ognuno ha il suo paniere: la difesa vale circa 1,9x i ricavi, le telecomunicazioni 2,7x, i fornitori di calcolo 7,9x. Non cerco un clone di SpaceX, cerco tre panieri.</a:t>
+              <a:t>Primo strumento, i multipli. Il corso dice che i comparabili devono avere stesso rischio e stessa crescita, e che trovarli è difficile. Per SpaceX un comparabile non esiste. Ma la SEC ci dà tre segmenti: Space, cioè lanci e contratti con NASA e Difesa; Starlink; e l'AI, cioè xAI. Ognuno ha il suo paniere: la difesa vale circa 1,9x i ricavi, Starlink 2,7x, cioè soprattutto telecom, con la parte governativa ai multipli della difesa, e i fornitori di calcolo 7,9x. Non cerco un clone di SpaceX, cerco tre panieri.</a:t>
             </a:r>
             <a:endParaRPr lang="en-US" dirty="0"/>
           </a:p>
@@ -2374,7 +2374,7 @@
           <a:p>
             <a:r>
               <a:rPr lang="en-US" dirty="0"/>
-              <a:t>Applico i tre panieri ai ricavi di quest'anno. SpaceX vale fra 144 e 187 miliardi, cioè 15-19 dollari per azione. Il mercato la paga più di dieci volte tanto. Anche valutando l'AI come OpenAI e Anthropic, fra 20 e 27 volte i ricavi, arrivo a 35-44 dollari. E per arrivare al prezzo Starlink dovrebbe valere 96x i ricavi, contro 2,7 delle telecom. Quindi il prezzo non è un prezzo relativo. Però i multipli di imprese mature non vedono la crescita: per questo serve il DCF.</a:t>
+              <a:t>Applico i tre panieri ai ricavi di quest'anno. SpaceX vale fra 144 e 187 miliardi, cioè 15-19 dollari per azione. Il mercato la paga più di dieci volte tanto. Anche valutando l'AI come OpenAI e Anthropic, fra 20 e 27 volte i ricavi, arrivo a 35-44 dollari. E per arrivare al prezzo Starlink dovrebbe valere 96x i ricavi, contro 2,7 del suo paniere, e fra gli operatori con ricavi veri nessuno supera 7,5. Quindi il prezzo non è un prezzo relativo. Però i multipli di imprese mature non vedono la crescita: per questo serve il DCF.</a:t>
             </a:r>
             <a:endParaRPr lang="en-US" dirty="0"/>
           </a:p>
@@ -8189,7 +8189,7 @@
                 <a:ea typeface="Inter" pitchFamily="34" charset="-122"/>
                 <a:cs typeface="Inter" pitchFamily="34" charset="-120"/>
               </a:rPr>
-              <a:t>il caso completo, 30 pagine, con tutti gli esibiti</a:t>
+              <a:t>il caso completo, 31 pagine, con tutti gli esibiti</a:t>
             </a:r>
             <a:endParaRPr lang="en-US" sz="1400" dirty="0"/>
           </a:p>
@@ -18431,7 +18431,7 @@
                 <a:ea typeface="Inter" pitchFamily="34" charset="-122"/>
                 <a:cs typeface="Inter" pitchFamily="34" charset="-120"/>
               </a:rPr>
-              <a:t>EV/ricavi del paniere: telecomunicazioni</a:t>
+              <a:t>EV/ricavi del paniere: telecom, più difesa per Starshield</a:t>
             </a:r>
             <a:endParaRPr lang="en-US" sz="1300" dirty="0"/>
           </a:p>
@@ -18658,7 +18658,7 @@
                 <a:ea typeface="Inter" pitchFamily="34" charset="-122"/>
                 <a:cs typeface="Inter" pitchFamily="34" charset="-120"/>
               </a:rPr>
-              <a:t>EV/ricavi del paniere: hyperscaler e cloud</a:t>
+              <a:t>EV/ricavi del paniere: hyperscaler, cloud e pubblicità</a:t>
             </a:r>
             <a:endParaRPr lang="en-US" sz="1300" dirty="0"/>
           </a:p>
@@ -19088,7 +19088,7 @@
                 <a:ea typeface="Inter" pitchFamily="34" charset="-122"/>
                 <a:cs typeface="Inter" pitchFamily="34" charset="-120"/>
               </a:rPr>
-              <a:t>i ricavi: quanto dovrebbe valere Starlink per arrivare al prezzo (telecom 2,7x)</a:t>
+              <a:t>i ricavi: quanto dovrebbe valere Starlink per arrivare al prezzo (il suo paniere: 2,7x)</a:t>
             </a:r>
             <a:endParaRPr lang="en-US" sz="1700" dirty="0"/>
           </a:p>

</xml_diff>

<commit_message>
Slide 6 e 14: chiarita la base dei ricavi (oggi contro 2036)
Co-Authored-By: Claude Opus 5.5 <noreply@anthropic.com>
</commit_message>
<xml_diff>
--- a/documenti/SpaceX_prezzo_e_valore.pptx
+++ b/documenti/SpaceX_prezzo_e_valore.pptx
@@ -967,7 +967,7 @@
           <a:p>
             <a:r>
               <a:rPr lang="en-US" dirty="0"/>
-              <a:t>Lo stesso risultato visto da un'altra parte. Nel mio DCF l'AI nel 2036 vale circa 6 volte l'EBITDA, il multiplo di un'impresa matura. Gli hyperscaler oggi valgono 22 volte. Se l'AI a regime valesse come loro, ma pesata per le probabilità, SpaceX varrebbe 103-111 dollari: ancora sotto il collocamento. Se in più l'AI riuscisse di sicuro, 152-183. Il prezzo, 167,60 $, sta esattamente lì: il mercato paga un'AI che vale come Microsoft e che riesce con certezza.</a:t>
+              <a:t>Lo stesso risultato visto da un'altra parte, e attenzione: non contraddice la slide 6. Lì il multiplo era applicato ai ricavi AI di oggi, 17 miliardi; qui ai ricavi che l'AI avrebbe nel 2036 se riesce, 550 miliardi. Nel mio DCF l'AI nel 2036 vale circa 6 volte l'EBITDA, il multiplo di un'impresa matura. Gli hyperscaler oggi valgono 22 volte. Se l'AI a regime valesse come loro, ma pesata per le probabilità, SpaceX varrebbe 103-111 dollari: ancora sotto il collocamento. Se in più l'AI riuscisse di sicuro, 152-183. Il prezzo, 167,60 $, sta esattamente lì: il mercato paga un'AI che vale come Microsoft e che riesce con certezza.</a:t>
             </a:r>
             <a:endParaRPr lang="en-US" dirty="0"/>
           </a:p>
@@ -2463,7 +2463,7 @@
           <a:p>
             <a:r>
               <a:rPr lang="en-US" dirty="0"/>
-              <a:t>Applico i tre panieri ai ricavi di quest'anno. SpaceX vale fra 144 e 187 miliardi, cioè 15-19 dollari per azione. Il mercato la paga più di dieci volte tanto. Anche valutando l'AI come OpenAI e Anthropic, fra 20 e 27 volte i ricavi, arrivo a 35-44 dollari. E per arrivare al prezzo Starlink dovrebbe valere 96x i ricavi, contro 2,7 del suo paniere, e fra gli operatori con ricavi veri nessuno supera 7,5. Quindi il prezzo non è un prezzo relativo. Però i multipli di imprese mature non vedono la crescita: per questo serve il DCF.</a:t>
+              <a:t>Applico i tre panieri ai ricavi di quest'anno, quelli di oggi. SpaceX vale fra 144 e 187 miliardi, cioè 15-19 dollari per azione. Il mercato la paga più di dieci volte tanto. Anche valutando l'AI come OpenAI e Anthropic, fra 20 e 27 volte i ricavi, arrivo a 35-44 dollari. E per arrivare al prezzo Starlink dovrebbe valere 96x i ricavi, contro 2,7 del suo paniere, e fra gli operatori con ricavi veri nessuno supera 7,5. Quindi il prezzo non è un prezzo relativo. Però i multipli di imprese mature non vedono la crescita: per questo serve il DCF.</a:t>
             </a:r>
             <a:endParaRPr lang="en-US" dirty="0"/>
           </a:p>
@@ -6749,6 +6749,45 @@
         </p:nvSpPr>
         <p:spPr>
           <a:xfrm>
+            <a:off x="548640" y="1600200"/>
+            <a:ext cx="11064240" cy="320040"/>
+          </a:xfrm>
+          <a:prstGeom prst="rect">
+            <a:avLst/>
+          </a:prstGeom>
+          <a:noFill/>
+          <a:ln/>
+        </p:spPr>
+        <p:txBody>
+          <a:bodyPr wrap="square" lIns="0" tIns="0" rIns="0" bIns="0" rtlCol="0" anchor="t"/>
+          <a:lstStyle/>
+          <a:p>
+            <a:pPr indent="0" marL="0">
+              <a:buNone/>
+            </a:pPr>
+            <a:r>
+              <a:rPr lang="en-US" sz="1400" dirty="0">
+                <a:solidFill>
+                  <a:srgbClr val="86868B"/>
+                </a:solidFill>
+                <a:latin typeface="Inter" pitchFamily="34" charset="0"/>
+                <a:ea typeface="Inter" pitchFamily="34" charset="-122"/>
+                <a:cs typeface="Inter" pitchFamily="34" charset="-120"/>
+              </a:rPr>
+              <a:t>Multipli dei comparabili sui ricavi AI del 2036 se riesce (550 mld), non su quelli di oggi (17 mld, slide 6)</a:t>
+            </a:r>
+            <a:endParaRPr lang="en-US" sz="1400" dirty="0"/>
+          </a:p>
+        </p:txBody>
+      </p:sp>
+      <p:sp>
+        <p:nvSpPr>
+          <p:cNvPr id="7" name="Text 4"/>
+          <p:cNvSpPr/>
+          <p:nvPr/>
+        </p:nvSpPr>
+        <p:spPr>
+          <a:xfrm>
             <a:off x="548640" y="2148840"/>
             <a:ext cx="6400800" cy="274320"/>
           </a:xfrm>
@@ -6782,7 +6821,7 @@
       </p:sp>
       <p:sp>
         <p:nvSpPr>
-          <p:cNvPr id="7" name="Text 4"/>
+          <p:cNvPr id="8" name="Text 5"/>
           <p:cNvSpPr/>
           <p:nvPr/>
         </p:nvSpPr>
@@ -6821,7 +6860,7 @@
       </p:sp>
       <p:sp>
         <p:nvSpPr>
-          <p:cNvPr id="8" name="Shape 5"/>
+          <p:cNvPr id="9" name="Shape 6"/>
           <p:cNvSpPr/>
           <p:nvPr/>
         </p:nvSpPr>
@@ -6844,7 +6883,7 @@
       </p:sp>
       <p:sp>
         <p:nvSpPr>
-          <p:cNvPr id="9" name="Text 6"/>
+          <p:cNvPr id="10" name="Text 7"/>
           <p:cNvSpPr/>
           <p:nvPr/>
         </p:nvSpPr>
@@ -6883,7 +6922,7 @@
       </p:sp>
       <p:sp>
         <p:nvSpPr>
-          <p:cNvPr id="10" name="Text 7"/>
+          <p:cNvPr id="11" name="Text 8"/>
           <p:cNvSpPr/>
           <p:nvPr/>
         </p:nvSpPr>
@@ -6922,7 +6961,7 @@
       </p:sp>
       <p:sp>
         <p:nvSpPr>
-          <p:cNvPr id="11" name="Shape 8"/>
+          <p:cNvPr id="12" name="Shape 9"/>
           <p:cNvSpPr/>
           <p:nvPr/>
         </p:nvSpPr>
@@ -6945,7 +6984,7 @@
       </p:sp>
       <p:sp>
         <p:nvSpPr>
-          <p:cNvPr id="12" name="Text 9"/>
+          <p:cNvPr id="13" name="Text 10"/>
           <p:cNvSpPr/>
           <p:nvPr/>
         </p:nvSpPr>
@@ -6984,7 +7023,7 @@
       </p:sp>
       <p:sp>
         <p:nvSpPr>
-          <p:cNvPr id="13" name="Text 10"/>
+          <p:cNvPr id="14" name="Text 11"/>
           <p:cNvSpPr/>
           <p:nvPr/>
         </p:nvSpPr>
@@ -7023,7 +7062,7 @@
       </p:sp>
       <p:sp>
         <p:nvSpPr>
-          <p:cNvPr id="14" name="Shape 11"/>
+          <p:cNvPr id="15" name="Shape 12"/>
           <p:cNvSpPr/>
           <p:nvPr/>
         </p:nvSpPr>
@@ -7046,7 +7085,7 @@
       </p:sp>
       <p:sp>
         <p:nvSpPr>
-          <p:cNvPr id="15" name="Text 12"/>
+          <p:cNvPr id="16" name="Text 13"/>
           <p:cNvSpPr/>
           <p:nvPr/>
         </p:nvSpPr>
@@ -7085,7 +7124,7 @@
       </p:sp>
       <p:sp>
         <p:nvSpPr>
-          <p:cNvPr id="16" name="Text 13"/>
+          <p:cNvPr id="17" name="Text 14"/>
           <p:cNvSpPr/>
           <p:nvPr/>
         </p:nvSpPr>
@@ -7124,7 +7163,7 @@
       </p:sp>
       <p:sp>
         <p:nvSpPr>
-          <p:cNvPr id="17" name="Shape 14"/>
+          <p:cNvPr id="18" name="Shape 15"/>
           <p:cNvSpPr/>
           <p:nvPr/>
         </p:nvSpPr>
@@ -7147,7 +7186,7 @@
       </p:sp>
       <p:sp>
         <p:nvSpPr>
-          <p:cNvPr id="18" name="Text 15"/>
+          <p:cNvPr id="19" name="Text 16"/>
           <p:cNvSpPr/>
           <p:nvPr/>
         </p:nvSpPr>
@@ -7186,7 +7225,7 @@
       </p:sp>
       <p:sp>
         <p:nvSpPr>
-          <p:cNvPr id="19" name="Text 16"/>
+          <p:cNvPr id="20" name="Text 17"/>
           <p:cNvSpPr/>
           <p:nvPr/>
         </p:nvSpPr>
@@ -7225,7 +7264,7 @@
       </p:sp>
       <p:sp>
         <p:nvSpPr>
-          <p:cNvPr id="20" name="Shape 17"/>
+          <p:cNvPr id="21" name="Shape 18"/>
           <p:cNvSpPr/>
           <p:nvPr/>
         </p:nvSpPr>
@@ -7248,7 +7287,7 @@
       </p:sp>
       <p:sp>
         <p:nvSpPr>
-          <p:cNvPr id="21" name="Text 18"/>
+          <p:cNvPr id="22" name="Text 19"/>
           <p:cNvSpPr/>
           <p:nvPr/>
         </p:nvSpPr>
@@ -19775,7 +19814,7 @@
                 <a:ea typeface="Inter" pitchFamily="34" charset="-122"/>
                 <a:cs typeface="Inter" pitchFamily="34" charset="-120"/>
               </a:rPr>
-              <a:t>SpaceX ai multipli dei suoi tre panieri</a:t>
+              <a:t>SpaceX ai multipli dei suoi tre panieri, sui ricavi di oggi (2026)</a:t>
             </a:r>
             <a:endParaRPr lang="en-US" sz="1700" dirty="0"/>
           </a:p>
@@ -19853,7 +19892,7 @@
                 <a:ea typeface="Inter" pitchFamily="34" charset="-122"/>
                 <a:cs typeface="Inter" pitchFamily="34" charset="-120"/>
               </a:rPr>
-              <a:t>con l'AI valutata come OpenAI e Anthropic</a:t>
+              <a:t>con l'AI valutata come OpenAI e Anthropic, sui suoi ricavi di oggi (17 mld)</a:t>
             </a:r>
             <a:endParaRPr lang="en-US" sz="1700" dirty="0"/>
           </a:p>

</xml_diff>